<commit_message>
Fix footer page numbers on slides 11 and 12
Slide 11 read "10" (duplicating slide 10) and slide 12 read "11"
instead of "12". Regenerates the matching PDF export.

Co-Authored-By: Claude Sonnet 5 <noreply@anthropic.com>
</commit_message>
<xml_diff>
--- a/presentation/Thomas_Hansen_Housing_Recommendation.pptx
+++ b/presentation/Thomas_Hansen_Housing_Recommendation.pptx
@@ -5164,7 +5164,7 @@
                 </a:solidFill>
                 <a:latin typeface="Calibri"/>
               </a:rPr>
-              <a:t>10</a:t>
+              <a:t>11</a:t>
             </a:r>
           </a:p>
         </p:txBody>
@@ -5382,7 +5382,7 @@
                 </a:solidFill>
                 <a:latin typeface="Calibri"/>
               </a:rPr>
-              <a:t>11</a:t>
+              <a:t>12</a:t>
             </a:r>
           </a:p>
         </p:txBody>

</xml_diff>